<commit_message>
Pricing deck: refresh HQ Recruit capability line + date for July presentation
Pricing itself is unchanged - the C10 model and every number in the deck
(HQ People $59/$179, Recruit add-on $40/$120, Bundle $89/$269, Foundation
$189, HR365 $799, Recruit365 $899, combined $1,599, one-offs $25-$79) still
match lib/pricing-config.ts exactly, so no pricing edits were needed. Two
small refreshes reflecting product work shipped since the deck was made:
- Slide 8: HQ Recruit description now leads with "Write the ad" (Campaign
  Coach) alongside score CVs / video + phone / shortlist - the recruit
  product gained the AI job-ad writer since June.
- Slide 1: "Partner briefing - June 2026" -> "July 2026" for this
  presentation.

Edited in place via the two slide XML entries; archive integrity verified,
16 slides intact.

Co-Authored-By: claude-flow <ruv@ruv.net>
</commit_message>
<xml_diff>
--- a/docs/HQai-price-modelling.pptx
+++ b/docs/HQai-price-modelling.pptx
@@ -2499,7 +2499,7 @@
                 <a:ea typeface="Calibri" pitchFamily="34" charset="-122"/>
                 <a:cs typeface="Calibri" pitchFamily="34" charset="-120"/>
               </a:rPr>
-              <a:t>Partner briefing  -  June 2026</a:t>
+              <a:t>Partner briefing  -  July 2026</a:t>
             </a:r>
             <a:endParaRPr lang="en-US" sz="1200" dirty="0"/>
           </a:p>
@@ -18578,7 +18578,7 @@
                 <a:ea typeface="Calibri" pitchFamily="34" charset="-122"/>
                 <a:cs typeface="Calibri" pitchFamily="34" charset="-120"/>
               </a:rPr>
-              <a:t>Score CVs, run video and phone interviews, build a shortlist. A metered add-on, paid when you hire.</a:t>
+              <a:t>Write the ad, score CVs, run video and phone interviews, shortlist. A metered add-on, paid when you hire.</a:t>
             </a:r>
             <a:endParaRPr lang="en-US" sz="1300" dirty="0"/>
           </a:p>

</xml_diff>